<commit_message>
image added to ppt.
</commit_message>
<xml_diff>
--- a/docs/01 RAG Architecture.pptx
+++ b/docs/01 RAG Architecture.pptx
@@ -21,14 +21,15 @@
     <p:sldId id="270" r:id="rId15"/>
     <p:sldId id="271" r:id="rId16"/>
     <p:sldId id="272" r:id="rId17"/>
-    <p:sldId id="260" r:id="rId18"/>
-    <p:sldId id="285" r:id="rId19"/>
-    <p:sldId id="286" r:id="rId20"/>
-    <p:sldId id="287" r:id="rId21"/>
-    <p:sldId id="288" r:id="rId22"/>
-    <p:sldId id="289" r:id="rId23"/>
-    <p:sldId id="282" r:id="rId24"/>
-    <p:sldId id="277" r:id="rId25"/>
+    <p:sldId id="290" r:id="rId18"/>
+    <p:sldId id="260" r:id="rId19"/>
+    <p:sldId id="285" r:id="rId20"/>
+    <p:sldId id="286" r:id="rId21"/>
+    <p:sldId id="287" r:id="rId22"/>
+    <p:sldId id="288" r:id="rId23"/>
+    <p:sldId id="289" r:id="rId24"/>
+    <p:sldId id="282" r:id="rId25"/>
+    <p:sldId id="277" r:id="rId26"/>
   </p:sldIdLst>
   <p:sldSz cx="12192000" cy="6858000"/>
   <p:notesSz cx="6858000" cy="9144000"/>
@@ -284,7 +285,7 @@
           <a:p>
             <a:fld id="{CF9BD994-088D-4DFC-A63A-488DD3725837}" type="datetimeFigureOut">
               <a:rPr lang="en-IN" smtClean="0"/>
-              <a:t>17-04-2026</a:t>
+              <a:t>22-09-2026</a:t>
             </a:fld>
             <a:endParaRPr lang="en-IN"/>
           </a:p>
@@ -484,7 +485,7 @@
           <a:p>
             <a:fld id="{CF9BD994-088D-4DFC-A63A-488DD3725837}" type="datetimeFigureOut">
               <a:rPr lang="en-IN" smtClean="0"/>
-              <a:t>17-04-2026</a:t>
+              <a:t>22-09-2026</a:t>
             </a:fld>
             <a:endParaRPr lang="en-IN"/>
           </a:p>
@@ -694,7 +695,7 @@
           <a:p>
             <a:fld id="{CF9BD994-088D-4DFC-A63A-488DD3725837}" type="datetimeFigureOut">
               <a:rPr lang="en-IN" smtClean="0"/>
-              <a:t>17-04-2026</a:t>
+              <a:t>22-09-2026</a:t>
             </a:fld>
             <a:endParaRPr lang="en-IN"/>
           </a:p>
@@ -916,7 +917,7 @@
           <a:p>
             <a:fld id="{4F816CEB-1072-4B22-A473-588D7AF62EB2}" type="datetimeFigureOut">
               <a:rPr lang="en-IN" smtClean="0"/>
-              <a:t>17-04-2026</a:t>
+              <a:t>22-09-2026</a:t>
             </a:fld>
             <a:endParaRPr lang="en-IN"/>
           </a:p>
@@ -1116,7 +1117,7 @@
           <a:p>
             <a:fld id="{4F816CEB-1072-4B22-A473-588D7AF62EB2}" type="datetimeFigureOut">
               <a:rPr lang="en-IN" smtClean="0"/>
-              <a:t>17-04-2026</a:t>
+              <a:t>22-09-2026</a:t>
             </a:fld>
             <a:endParaRPr lang="en-IN"/>
           </a:p>
@@ -1392,7 +1393,7 @@
           <a:p>
             <a:fld id="{4F816CEB-1072-4B22-A473-588D7AF62EB2}" type="datetimeFigureOut">
               <a:rPr lang="en-IN" smtClean="0"/>
-              <a:t>17-04-2026</a:t>
+              <a:t>22-09-2026</a:t>
             </a:fld>
             <a:endParaRPr lang="en-IN"/>
           </a:p>
@@ -1660,7 +1661,7 @@
           <a:p>
             <a:fld id="{4F816CEB-1072-4B22-A473-588D7AF62EB2}" type="datetimeFigureOut">
               <a:rPr lang="en-IN" smtClean="0"/>
-              <a:t>17-04-2026</a:t>
+              <a:t>22-09-2026</a:t>
             </a:fld>
             <a:endParaRPr lang="en-IN"/>
           </a:p>
@@ -2075,7 +2076,7 @@
           <a:p>
             <a:fld id="{4F816CEB-1072-4B22-A473-588D7AF62EB2}" type="datetimeFigureOut">
               <a:rPr lang="en-IN" smtClean="0"/>
-              <a:t>17-04-2026</a:t>
+              <a:t>22-09-2026</a:t>
             </a:fld>
             <a:endParaRPr lang="en-IN"/>
           </a:p>
@@ -2217,7 +2218,7 @@
           <a:p>
             <a:fld id="{4F816CEB-1072-4B22-A473-588D7AF62EB2}" type="datetimeFigureOut">
               <a:rPr lang="en-IN" smtClean="0"/>
-              <a:t>17-04-2026</a:t>
+              <a:t>22-09-2026</a:t>
             </a:fld>
             <a:endParaRPr lang="en-IN"/>
           </a:p>
@@ -2330,7 +2331,7 @@
           <a:p>
             <a:fld id="{4F816CEB-1072-4B22-A473-588D7AF62EB2}" type="datetimeFigureOut">
               <a:rPr lang="en-IN" smtClean="0"/>
-              <a:t>17-04-2026</a:t>
+              <a:t>22-09-2026</a:t>
             </a:fld>
             <a:endParaRPr lang="en-IN"/>
           </a:p>
@@ -2643,7 +2644,7 @@
           <a:p>
             <a:fld id="{4F816CEB-1072-4B22-A473-588D7AF62EB2}" type="datetimeFigureOut">
               <a:rPr lang="en-IN" smtClean="0"/>
-              <a:t>17-04-2026</a:t>
+              <a:t>22-09-2026</a:t>
             </a:fld>
             <a:endParaRPr lang="en-IN"/>
           </a:p>
@@ -2843,7 +2844,7 @@
           <a:p>
             <a:fld id="{CF9BD994-088D-4DFC-A63A-488DD3725837}" type="datetimeFigureOut">
               <a:rPr lang="en-IN" smtClean="0"/>
-              <a:t>17-04-2026</a:t>
+              <a:t>22-09-2026</a:t>
             </a:fld>
             <a:endParaRPr lang="en-IN"/>
           </a:p>
@@ -3132,7 +3133,7 @@
           <a:p>
             <a:fld id="{4F816CEB-1072-4B22-A473-588D7AF62EB2}" type="datetimeFigureOut">
               <a:rPr lang="en-IN" smtClean="0"/>
-              <a:t>17-04-2026</a:t>
+              <a:t>22-09-2026</a:t>
             </a:fld>
             <a:endParaRPr lang="en-IN"/>
           </a:p>
@@ -3332,7 +3333,7 @@
           <a:p>
             <a:fld id="{4F816CEB-1072-4B22-A473-588D7AF62EB2}" type="datetimeFigureOut">
               <a:rPr lang="en-IN" smtClean="0"/>
-              <a:t>17-04-2026</a:t>
+              <a:t>22-09-2026</a:t>
             </a:fld>
             <a:endParaRPr lang="en-IN"/>
           </a:p>
@@ -3542,7 +3543,7 @@
           <a:p>
             <a:fld id="{4F816CEB-1072-4B22-A473-588D7AF62EB2}" type="datetimeFigureOut">
               <a:rPr lang="en-IN" smtClean="0"/>
-              <a:t>17-04-2026</a:t>
+              <a:t>22-09-2026</a:t>
             </a:fld>
             <a:endParaRPr lang="en-IN"/>
           </a:p>
@@ -3928,7 +3929,7 @@
           <a:p>
             <a:fld id="{CF9BD994-088D-4DFC-A63A-488DD3725837}" type="datetimeFigureOut">
               <a:rPr lang="en-IN" smtClean="0"/>
-              <a:t>17-04-2026</a:t>
+              <a:t>22-09-2026</a:t>
             </a:fld>
             <a:endParaRPr lang="en-IN"/>
           </a:p>
@@ -4196,7 +4197,7 @@
           <a:p>
             <a:fld id="{CF9BD994-088D-4DFC-A63A-488DD3725837}" type="datetimeFigureOut">
               <a:rPr lang="en-IN" smtClean="0"/>
-              <a:t>17-04-2026</a:t>
+              <a:t>22-09-2026</a:t>
             </a:fld>
             <a:endParaRPr lang="en-IN"/>
           </a:p>
@@ -4611,7 +4612,7 @@
           <a:p>
             <a:fld id="{CF9BD994-088D-4DFC-A63A-488DD3725837}" type="datetimeFigureOut">
               <a:rPr lang="en-IN" smtClean="0"/>
-              <a:t>17-04-2026</a:t>
+              <a:t>22-09-2026</a:t>
             </a:fld>
             <a:endParaRPr lang="en-IN"/>
           </a:p>
@@ -4753,7 +4754,7 @@
           <a:p>
             <a:fld id="{CF9BD994-088D-4DFC-A63A-488DD3725837}" type="datetimeFigureOut">
               <a:rPr lang="en-IN" smtClean="0"/>
-              <a:t>17-04-2026</a:t>
+              <a:t>22-09-2026</a:t>
             </a:fld>
             <a:endParaRPr lang="en-IN"/>
           </a:p>
@@ -4866,7 +4867,7 @@
           <a:p>
             <a:fld id="{CF9BD994-088D-4DFC-A63A-488DD3725837}" type="datetimeFigureOut">
               <a:rPr lang="en-IN" smtClean="0"/>
-              <a:t>17-04-2026</a:t>
+              <a:t>22-09-2026</a:t>
             </a:fld>
             <a:endParaRPr lang="en-IN"/>
           </a:p>
@@ -5179,7 +5180,7 @@
           <a:p>
             <a:fld id="{CF9BD994-088D-4DFC-A63A-488DD3725837}" type="datetimeFigureOut">
               <a:rPr lang="en-IN" smtClean="0"/>
-              <a:t>17-04-2026</a:t>
+              <a:t>22-09-2026</a:t>
             </a:fld>
             <a:endParaRPr lang="en-IN"/>
           </a:p>
@@ -5468,7 +5469,7 @@
           <a:p>
             <a:fld id="{CF9BD994-088D-4DFC-A63A-488DD3725837}" type="datetimeFigureOut">
               <a:rPr lang="en-IN" smtClean="0"/>
-              <a:t>17-04-2026</a:t>
+              <a:t>22-09-2026</a:t>
             </a:fld>
             <a:endParaRPr lang="en-IN"/>
           </a:p>
@@ -5711,7 +5712,7 @@
           <a:p>
             <a:fld id="{CF9BD994-088D-4DFC-A63A-488DD3725837}" type="datetimeFigureOut">
               <a:rPr lang="en-IN" smtClean="0"/>
-              <a:t>17-04-2026</a:t>
+              <a:t>22-09-2026</a:t>
             </a:fld>
             <a:endParaRPr lang="en-IN"/>
           </a:p>
@@ -6281,7 +6282,7 @@
           <a:p>
             <a:fld id="{4F816CEB-1072-4B22-A473-588D7AF62EB2}" type="datetimeFigureOut">
               <a:rPr lang="en-IN" smtClean="0"/>
-              <a:t>17-04-2026</a:t>
+              <a:t>22-09-2026</a:t>
             </a:fld>
             <a:endParaRPr lang="en-IN"/>
           </a:p>
@@ -7769,6 +7770,14 @@
 <file path=ppt/slides/slide16.xml><?xml version="1.0" encoding="utf-8"?>
 <p:sld xmlns:a="http://schemas.openxmlformats.org/drawingml/2006/main" xmlns:r="http://schemas.openxmlformats.org/officeDocument/2006/relationships" xmlns:p="http://schemas.openxmlformats.org/presentationml/2006/main">
   <p:cSld>
+    <p:bg>
+      <p:bgPr>
+        <a:solidFill>
+          <a:schemeClr val="bg1"/>
+        </a:solidFill>
+        <a:effectLst/>
+      </p:bgPr>
+    </p:bg>
     <p:spTree>
       <p:nvGrpSpPr>
         <p:cNvPr id="1" name=""/>
@@ -7783,213 +7792,177 @@
           <a:chExt cx="0" cy="0"/>
         </a:xfrm>
       </p:grpSpPr>
-      <p:sp>
-        <p:nvSpPr>
-          <p:cNvPr id="2" name="Title 1">
-            <a:extLst>
-              <a:ext uri="{FF2B5EF4-FFF2-40B4-BE49-F238E27FC236}">
-                <a16:creationId xmlns:a16="http://schemas.microsoft.com/office/drawing/2014/main" id="{BE1C8AA8-8BED-27D0-E5D5-9217A8D35E0B}"/>
-              </a:ext>
-            </a:extLst>
-          </p:cNvPr>
-          <p:cNvSpPr>
-            <a:spLocks noGrp="1"/>
-          </p:cNvSpPr>
-          <p:nvPr>
-            <p:ph type="title"/>
-          </p:nvPr>
-        </p:nvSpPr>
-        <p:spPr/>
-        <p:txBody>
-          <a:bodyPr/>
-          <a:lstStyle/>
-          <a:p>
-            <a:r>
-              <a:rPr lang="en-IN" dirty="0"/>
-              <a:t>Output Evaluation – Grounded vs Hallucinated</a:t>
-            </a:r>
-          </a:p>
-        </p:txBody>
-      </p:sp>
-      <p:sp>
-        <p:nvSpPr>
-          <p:cNvPr id="3" name="Content Placeholder 2">
-            <a:extLst>
-              <a:ext uri="{FF2B5EF4-FFF2-40B4-BE49-F238E27FC236}">
-                <a16:creationId xmlns:a16="http://schemas.microsoft.com/office/drawing/2014/main" id="{0D13FF52-2AF7-4398-9F44-F5EF3315FE1E}"/>
-              </a:ext>
-            </a:extLst>
-          </p:cNvPr>
-          <p:cNvSpPr>
-            <a:spLocks noGrp="1"/>
-          </p:cNvSpPr>
+      <p:sp useBgFill="1">
+        <p:nvSpPr>
+          <p:cNvPr id="13" name="Rectangle 12">
+            <a:extLst>
+              <a:ext uri="{FF2B5EF4-FFF2-40B4-BE49-F238E27FC236}">
+                <a16:creationId xmlns:a16="http://schemas.microsoft.com/office/drawing/2014/main" id="{E722B2DD-E14D-4972-9D98-5D6E61B1B2D2}"/>
+              </a:ext>
+              <a:ext uri="{C183D7F6-B498-43B3-948B-1728B52AA6E4}">
+                <adec:decorative xmlns:adec="http://schemas.microsoft.com/office/drawing/2017/decorative" val="1"/>
+              </a:ext>
+            </a:extLst>
+          </p:cNvPr>
+          <p:cNvSpPr>
+            <a:spLocks noGrp="1" noRot="1" noChangeAspect="1" noMove="1" noResize="1" noEditPoints="1" noAdjustHandles="1" noChangeArrowheads="1" noChangeShapeType="1" noTextEdit="1"/>
+          </p:cNvSpPr>
+          <p:nvPr>
+            <p:extLst>
+              <p:ext uri="{386F3935-93C4-4BCD-93E2-E3B085C9AB24}">
+                <p16:designElem xmlns:p16="http://schemas.microsoft.com/office/powerpoint/2015/main" val="1"/>
+              </p:ext>
+            </p:extLst>
+          </p:nvPr>
+        </p:nvSpPr>
+        <p:spPr>
+          <a:xfrm>
+            <a:off x="0" y="0"/>
+            <a:ext cx="12192000" cy="6858000"/>
+          </a:xfrm>
+          <a:prstGeom prst="rect">
+            <a:avLst/>
+          </a:prstGeom>
+          <a:ln>
+            <a:noFill/>
+          </a:ln>
+          <a:effectLst/>
+        </p:spPr>
+        <p:style>
+          <a:lnRef idx="2">
+            <a:schemeClr val="accent1">
+              <a:shade val="50000"/>
+            </a:schemeClr>
+          </a:lnRef>
+          <a:fillRef idx="1">
+            <a:schemeClr val="accent1"/>
+          </a:fillRef>
+          <a:effectRef idx="0">
+            <a:schemeClr val="accent1"/>
+          </a:effectRef>
+          <a:fontRef idx="minor">
+            <a:schemeClr val="lt1"/>
+          </a:fontRef>
+        </p:style>
+        <p:txBody>
+          <a:bodyPr rtlCol="0" anchor="ctr"/>
+          <a:lstStyle/>
+          <a:p>
+            <a:pPr algn="ctr"/>
+            <a:endParaRPr lang="en-US"/>
+          </a:p>
+        </p:txBody>
+      </p:sp>
+      <p:sp useBgFill="1">
+        <p:nvSpPr>
+          <p:cNvPr id="12" name="Rectangle 11">
+            <a:extLst>
+              <a:ext uri="{FF2B5EF4-FFF2-40B4-BE49-F238E27FC236}">
+                <a16:creationId xmlns:a16="http://schemas.microsoft.com/office/drawing/2014/main" id="{0CFB124C-4B0C-4A81-8633-17257B151642}"/>
+              </a:ext>
+              <a:ext uri="{C183D7F6-B498-43B3-948B-1728B52AA6E4}">
+                <adec:decorative xmlns:adec="http://schemas.microsoft.com/office/drawing/2017/decorative" val="1"/>
+              </a:ext>
+            </a:extLst>
+          </p:cNvPr>
+          <p:cNvSpPr>
+            <a:spLocks noGrp="1" noRot="1" noChangeAspect="1" noMove="1" noResize="1" noEditPoints="1" noAdjustHandles="1" noChangeArrowheads="1" noChangeShapeType="1" noTextEdit="1"/>
+          </p:cNvSpPr>
+          <p:nvPr>
+            <p:extLst>
+              <p:ext uri="{386F3935-93C4-4BCD-93E2-E3B085C9AB24}">
+                <p16:designElem xmlns:p16="http://schemas.microsoft.com/office/powerpoint/2015/main" val="1"/>
+              </p:ext>
+            </p:extLst>
+          </p:nvPr>
+        </p:nvSpPr>
+        <p:spPr>
+          <a:xfrm>
+            <a:off x="1882006" y="569844"/>
+            <a:ext cx="8427988" cy="5649981"/>
+          </a:xfrm>
+          <a:prstGeom prst="rect">
+            <a:avLst/>
+          </a:prstGeom>
+          <a:ln>
+            <a:noFill/>
+          </a:ln>
+          <a:effectLst>
+            <a:outerShdw blurRad="317500" dist="317500" dir="7140000" sx="95000" sy="95000" algn="t" rotWithShape="0">
+              <a:srgbClr val="000000">
+                <a:alpha val="25000"/>
+              </a:srgbClr>
+            </a:outerShdw>
+          </a:effectLst>
+        </p:spPr>
+        <p:style>
+          <a:lnRef idx="2">
+            <a:schemeClr val="accent1">
+              <a:shade val="50000"/>
+            </a:schemeClr>
+          </a:lnRef>
+          <a:fillRef idx="1">
+            <a:schemeClr val="accent1"/>
+          </a:fillRef>
+          <a:effectRef idx="0">
+            <a:schemeClr val="accent1"/>
+          </a:effectRef>
+          <a:fontRef idx="minor">
+            <a:schemeClr val="lt1"/>
+          </a:fontRef>
+        </p:style>
+        <p:txBody>
+          <a:bodyPr rtlCol="0" anchor="ctr"/>
+          <a:lstStyle/>
+          <a:p>
+            <a:pPr algn="ctr"/>
+            <a:endParaRPr lang="en-US" dirty="0"/>
+          </a:p>
+        </p:txBody>
+      </p:sp>
+      <p:pic>
+        <p:nvPicPr>
+          <p:cNvPr id="5" name="Content Placeholder 4">
+            <a:extLst>
+              <a:ext uri="{FF2B5EF4-FFF2-40B4-BE49-F238E27FC236}">
+                <a16:creationId xmlns:a16="http://schemas.microsoft.com/office/drawing/2014/main" id="{A71E86AD-E2C0-674B-97CB-D1D183310BB4}"/>
+              </a:ext>
+            </a:extLst>
+          </p:cNvPr>
+          <p:cNvPicPr>
+            <a:picLocks noGrp="1" noChangeAspect="1"/>
+          </p:cNvPicPr>
           <p:nvPr>
             <p:ph idx="1"/>
           </p:nvPr>
-        </p:nvSpPr>
-        <p:spPr/>
-        <p:txBody>
-          <a:bodyPr>
-            <a:normAutofit fontScale="47500" lnSpcReduction="20000"/>
-          </a:bodyPr>
-          <a:lstStyle/>
-          <a:p>
-            <a:r>
-              <a:rPr lang="en-US" b="1" dirty="0"/>
-              <a:t>Why it matters</a:t>
-            </a:r>
-          </a:p>
-          <a:p>
-            <a:pPr lvl="1"/>
-            <a:r>
-              <a:rPr lang="en-US" dirty="0"/>
-              <a:t>Even with RAG, AI can still:</a:t>
-            </a:r>
-          </a:p>
-          <a:p>
-            <a:pPr lvl="1"/>
-            <a:r>
-              <a:rPr lang="en-US" dirty="0"/>
-              <a:t>Misinterpret retrieved data </a:t>
-            </a:r>
-          </a:p>
-          <a:p>
-            <a:pPr lvl="1"/>
-            <a:r>
-              <a:rPr lang="en-US" dirty="0"/>
-              <a:t>Combine facts incorrectly </a:t>
-            </a:r>
-          </a:p>
-          <a:p>
-            <a:endParaRPr lang="en-US" dirty="0"/>
-          </a:p>
-          <a:p>
-            <a:r>
-              <a:rPr lang="en-US" b="1" dirty="0"/>
-              <a:t>Grounded Response</a:t>
-            </a:r>
-          </a:p>
-          <a:p>
-            <a:pPr lvl="1"/>
-            <a:r>
-              <a:rPr lang="en-US" dirty="0"/>
-              <a:t>Based on retrieved documents </a:t>
-            </a:r>
-          </a:p>
-          <a:p>
-            <a:pPr lvl="1"/>
-            <a:r>
-              <a:rPr lang="en-US" dirty="0"/>
-              <a:t>Includes references </a:t>
-            </a:r>
-          </a:p>
-          <a:p>
-            <a:pPr lvl="1"/>
-            <a:endParaRPr lang="en-US" b="1" dirty="0"/>
-          </a:p>
-          <a:p>
-            <a:pPr lvl="1"/>
-            <a:r>
-              <a:rPr lang="en-US" b="1" dirty="0"/>
-              <a:t>Example</a:t>
-            </a:r>
-          </a:p>
-          <a:p>
-            <a:pPr marL="914400" lvl="2" indent="0">
-              <a:buNone/>
-            </a:pPr>
-            <a:r>
-              <a:rPr lang="en-US" i="1" dirty="0">
-                <a:latin typeface="Cascadia Code" panose="020B0609020000020004" pitchFamily="49" charset="0"/>
-                <a:cs typeface="Cascadia Code" panose="020B0609020000020004" pitchFamily="49" charset="0"/>
-              </a:rPr>
-              <a:t>"As per HR Policy Section 5.1, employees are eligible for 20 days leave."</a:t>
-            </a:r>
-            <a:endParaRPr lang="en-US" dirty="0">
-              <a:latin typeface="Cascadia Code" panose="020B0609020000020004" pitchFamily="49" charset="0"/>
-              <a:cs typeface="Cascadia Code" panose="020B0609020000020004" pitchFamily="49" charset="0"/>
-            </a:endParaRPr>
-          </a:p>
-          <a:p>
-            <a:pPr lvl="2"/>
-            <a:r>
-              <a:rPr lang="en-US" dirty="0"/>
-              <a:t>Traceable</a:t>
-            </a:r>
-          </a:p>
-          <a:p>
-            <a:pPr lvl="2"/>
-            <a:r>
-              <a:rPr lang="en-US" dirty="0"/>
-              <a:t>Verifiable</a:t>
-            </a:r>
-          </a:p>
-          <a:p>
-            <a:endParaRPr lang="en-US" dirty="0"/>
-          </a:p>
-          <a:p>
-            <a:r>
-              <a:rPr lang="en-US" b="1" dirty="0"/>
-              <a:t>Hallucinated Response</a:t>
-            </a:r>
-          </a:p>
-          <a:p>
-            <a:pPr lvl="1"/>
-            <a:r>
-              <a:rPr lang="en-US" dirty="0"/>
-              <a:t>No source or incorrect interpretation </a:t>
-            </a:r>
-          </a:p>
-          <a:p>
-            <a:pPr lvl="1"/>
-            <a:endParaRPr lang="en-US" b="1" dirty="0"/>
-          </a:p>
-          <a:p>
-            <a:pPr lvl="1"/>
-            <a:r>
-              <a:rPr lang="en-US" b="1" dirty="0"/>
-              <a:t>Example</a:t>
-            </a:r>
-          </a:p>
-          <a:p>
-            <a:pPr marL="457200" lvl="1" indent="0">
-              <a:buNone/>
-            </a:pPr>
-            <a:r>
-              <a:rPr lang="en-US" i="1" dirty="0">
-                <a:latin typeface="Cascadia Code" panose="020B0609020000020004" pitchFamily="49" charset="0"/>
-                <a:cs typeface="Cascadia Code" panose="020B0609020000020004" pitchFamily="49" charset="0"/>
-              </a:rPr>
-              <a:t>"Employees typically get 25 days leave annually."</a:t>
-            </a:r>
-            <a:endParaRPr lang="en-US" dirty="0">
-              <a:latin typeface="Cascadia Code" panose="020B0609020000020004" pitchFamily="49" charset="0"/>
-              <a:cs typeface="Cascadia Code" panose="020B0609020000020004" pitchFamily="49" charset="0"/>
-            </a:endParaRPr>
-          </a:p>
-          <a:p>
-            <a:pPr lvl="2"/>
-            <a:r>
-              <a:rPr lang="en-US" dirty="0"/>
-              <a:t> Sounds reasonable</a:t>
-            </a:r>
-          </a:p>
-          <a:p>
-            <a:pPr lvl="2"/>
-            <a:r>
-              <a:rPr lang="en-US" dirty="0"/>
-              <a:t>But not in your policy</a:t>
-            </a:r>
-          </a:p>
-          <a:p>
-            <a:endParaRPr lang="en-IN" dirty="0"/>
-          </a:p>
-        </p:txBody>
-      </p:sp>
+        </p:nvPicPr>
+        <p:blipFill>
+          <a:blip r:embed="rId2">
+            <a:extLst>
+              <a:ext uri="{28A0092B-C50C-407E-A947-70E740481C1C}">
+                <a14:useLocalDpi xmlns:a14="http://schemas.microsoft.com/office/drawing/2010/main" val="0"/>
+              </a:ext>
+            </a:extLst>
+          </a:blip>
+          <a:srcRect l="162"/>
+          <a:stretch>
+            <a:fillRect/>
+          </a:stretch>
+        </p:blipFill>
+        <p:spPr>
+          <a:xfrm>
+            <a:off x="1882006" y="569843"/>
+            <a:ext cx="8450714" cy="5649981"/>
+          </a:xfrm>
+          <a:prstGeom prst="rect">
+            <a:avLst/>
+          </a:prstGeom>
+        </p:spPr>
+      </p:pic>
     </p:spTree>
     <p:extLst>
       <p:ext uri="{BB962C8B-B14F-4D97-AF65-F5344CB8AC3E}">
-        <p14:creationId xmlns:p14="http://schemas.microsoft.com/office/powerpoint/2010/main" val="2677211404"/>
+        <p14:creationId xmlns:p14="http://schemas.microsoft.com/office/powerpoint/2010/main" val="3109538527"/>
       </p:ext>
     </p:extLst>
   </p:cSld>
@@ -8021,6 +7994,239 @@
           <p:cNvPr id="2" name="Title 1">
             <a:extLst>
               <a:ext uri="{FF2B5EF4-FFF2-40B4-BE49-F238E27FC236}">
+                <a16:creationId xmlns:a16="http://schemas.microsoft.com/office/drawing/2014/main" id="{BE1C8AA8-8BED-27D0-E5D5-9217A8D35E0B}"/>
+              </a:ext>
+            </a:extLst>
+          </p:cNvPr>
+          <p:cNvSpPr>
+            <a:spLocks noGrp="1"/>
+          </p:cNvSpPr>
+          <p:nvPr>
+            <p:ph type="title"/>
+          </p:nvPr>
+        </p:nvSpPr>
+        <p:spPr/>
+        <p:txBody>
+          <a:bodyPr/>
+          <a:lstStyle/>
+          <a:p>
+            <a:r>
+              <a:rPr lang="en-IN" dirty="0"/>
+              <a:t>Output Evaluation – Grounded vs Hallucinated</a:t>
+            </a:r>
+          </a:p>
+        </p:txBody>
+      </p:sp>
+      <p:sp>
+        <p:nvSpPr>
+          <p:cNvPr id="3" name="Content Placeholder 2">
+            <a:extLst>
+              <a:ext uri="{FF2B5EF4-FFF2-40B4-BE49-F238E27FC236}">
+                <a16:creationId xmlns:a16="http://schemas.microsoft.com/office/drawing/2014/main" id="{0D13FF52-2AF7-4398-9F44-F5EF3315FE1E}"/>
+              </a:ext>
+            </a:extLst>
+          </p:cNvPr>
+          <p:cNvSpPr>
+            <a:spLocks noGrp="1"/>
+          </p:cNvSpPr>
+          <p:nvPr>
+            <p:ph idx="1"/>
+          </p:nvPr>
+        </p:nvSpPr>
+        <p:spPr/>
+        <p:txBody>
+          <a:bodyPr>
+            <a:normAutofit fontScale="47500" lnSpcReduction="20000"/>
+          </a:bodyPr>
+          <a:lstStyle/>
+          <a:p>
+            <a:r>
+              <a:rPr lang="en-US" b="1" dirty="0"/>
+              <a:t>Why it matters</a:t>
+            </a:r>
+          </a:p>
+          <a:p>
+            <a:pPr lvl="1"/>
+            <a:r>
+              <a:rPr lang="en-US" dirty="0"/>
+              <a:t>Even with RAG, AI can still:</a:t>
+            </a:r>
+          </a:p>
+          <a:p>
+            <a:pPr lvl="2"/>
+            <a:r>
+              <a:rPr lang="en-US" dirty="0"/>
+              <a:t>Misinterpret retrieved data </a:t>
+            </a:r>
+          </a:p>
+          <a:p>
+            <a:pPr lvl="2"/>
+            <a:r>
+              <a:rPr lang="en-US" dirty="0"/>
+              <a:t>Combine facts incorrectly </a:t>
+            </a:r>
+          </a:p>
+          <a:p>
+            <a:endParaRPr lang="en-US" dirty="0"/>
+          </a:p>
+          <a:p>
+            <a:r>
+              <a:rPr lang="en-US" b="1" dirty="0"/>
+              <a:t>Grounded Response</a:t>
+            </a:r>
+          </a:p>
+          <a:p>
+            <a:pPr lvl="1"/>
+            <a:r>
+              <a:rPr lang="en-US" dirty="0"/>
+              <a:t>Based on retrieved documents </a:t>
+            </a:r>
+          </a:p>
+          <a:p>
+            <a:pPr lvl="1"/>
+            <a:r>
+              <a:rPr lang="en-US" dirty="0"/>
+              <a:t>Includes references </a:t>
+            </a:r>
+          </a:p>
+          <a:p>
+            <a:pPr lvl="1"/>
+            <a:endParaRPr lang="en-US" b="1" dirty="0"/>
+          </a:p>
+          <a:p>
+            <a:pPr lvl="1"/>
+            <a:r>
+              <a:rPr lang="en-US" b="1" dirty="0"/>
+              <a:t>Example</a:t>
+            </a:r>
+          </a:p>
+          <a:p>
+            <a:pPr marL="914400" lvl="2" indent="0">
+              <a:buNone/>
+            </a:pPr>
+            <a:r>
+              <a:rPr lang="en-US" i="1" dirty="0">
+                <a:latin typeface="Cascadia Code" panose="020B0609020000020004" pitchFamily="49" charset="0"/>
+                <a:cs typeface="Cascadia Code" panose="020B0609020000020004" pitchFamily="49" charset="0"/>
+              </a:rPr>
+              <a:t>"As per HR Policy Section 5.1, employees are eligible for 20 days leave."</a:t>
+            </a:r>
+            <a:endParaRPr lang="en-US" dirty="0">
+              <a:latin typeface="Cascadia Code" panose="020B0609020000020004" pitchFamily="49" charset="0"/>
+              <a:cs typeface="Cascadia Code" panose="020B0609020000020004" pitchFamily="49" charset="0"/>
+            </a:endParaRPr>
+          </a:p>
+          <a:p>
+            <a:pPr lvl="2"/>
+            <a:r>
+              <a:rPr lang="en-US" dirty="0"/>
+              <a:t>Traceable</a:t>
+            </a:r>
+          </a:p>
+          <a:p>
+            <a:pPr lvl="2"/>
+            <a:r>
+              <a:rPr lang="en-US" dirty="0"/>
+              <a:t>Verifiable</a:t>
+            </a:r>
+          </a:p>
+          <a:p>
+            <a:endParaRPr lang="en-US" dirty="0"/>
+          </a:p>
+          <a:p>
+            <a:r>
+              <a:rPr lang="en-US" b="1" dirty="0"/>
+              <a:t>Hallucinated Response</a:t>
+            </a:r>
+          </a:p>
+          <a:p>
+            <a:pPr lvl="1"/>
+            <a:r>
+              <a:rPr lang="en-US" dirty="0"/>
+              <a:t>No source or incorrect interpretation </a:t>
+            </a:r>
+          </a:p>
+          <a:p>
+            <a:pPr lvl="1"/>
+            <a:endParaRPr lang="en-US" b="1" dirty="0"/>
+          </a:p>
+          <a:p>
+            <a:pPr lvl="1"/>
+            <a:r>
+              <a:rPr lang="en-US" b="1" dirty="0"/>
+              <a:t>Example</a:t>
+            </a:r>
+          </a:p>
+          <a:p>
+            <a:pPr marL="457200" lvl="1" indent="0">
+              <a:buNone/>
+            </a:pPr>
+            <a:r>
+              <a:rPr lang="en-US" i="1" dirty="0">
+                <a:latin typeface="Cascadia Code" panose="020B0609020000020004" pitchFamily="49" charset="0"/>
+                <a:cs typeface="Cascadia Code" panose="020B0609020000020004" pitchFamily="49" charset="0"/>
+              </a:rPr>
+              <a:t>"Employees typically get 25 days leave annually."</a:t>
+            </a:r>
+            <a:endParaRPr lang="en-US" dirty="0">
+              <a:latin typeface="Cascadia Code" panose="020B0609020000020004" pitchFamily="49" charset="0"/>
+              <a:cs typeface="Cascadia Code" panose="020B0609020000020004" pitchFamily="49" charset="0"/>
+            </a:endParaRPr>
+          </a:p>
+          <a:p>
+            <a:pPr lvl="2"/>
+            <a:r>
+              <a:rPr lang="en-US" dirty="0"/>
+              <a:t> Sounds reasonable</a:t>
+            </a:r>
+          </a:p>
+          <a:p>
+            <a:pPr lvl="2"/>
+            <a:r>
+              <a:rPr lang="en-US" dirty="0"/>
+              <a:t>But not in your policy</a:t>
+            </a:r>
+          </a:p>
+          <a:p>
+            <a:endParaRPr lang="en-IN" dirty="0"/>
+          </a:p>
+        </p:txBody>
+      </p:sp>
+    </p:spTree>
+    <p:extLst>
+      <p:ext uri="{BB962C8B-B14F-4D97-AF65-F5344CB8AC3E}">
+        <p14:creationId xmlns:p14="http://schemas.microsoft.com/office/powerpoint/2010/main" val="2677211404"/>
+      </p:ext>
+    </p:extLst>
+  </p:cSld>
+  <p:clrMapOvr>
+    <a:masterClrMapping/>
+  </p:clrMapOvr>
+</p:sld>
+</file>
+
+<file path=ppt/slides/slide18.xml><?xml version="1.0" encoding="utf-8"?>
+<p:sld xmlns:a="http://schemas.openxmlformats.org/drawingml/2006/main" xmlns:r="http://schemas.openxmlformats.org/officeDocument/2006/relationships" xmlns:p="http://schemas.openxmlformats.org/presentationml/2006/main">
+  <p:cSld>
+    <p:spTree>
+      <p:nvGrpSpPr>
+        <p:cNvPr id="1" name=""/>
+        <p:cNvGrpSpPr/>
+        <p:nvPr/>
+      </p:nvGrpSpPr>
+      <p:grpSpPr>
+        <a:xfrm>
+          <a:off x="0" y="0"/>
+          <a:ext cx="0" cy="0"/>
+          <a:chOff x="0" y="0"/>
+          <a:chExt cx="0" cy="0"/>
+        </a:xfrm>
+      </p:grpSpPr>
+      <p:sp>
+        <p:nvSpPr>
+          <p:cNvPr id="2" name="Title 1">
+            <a:extLst>
+              <a:ext uri="{FF2B5EF4-FFF2-40B4-BE49-F238E27FC236}">
                 <a16:creationId xmlns:a16="http://schemas.microsoft.com/office/drawing/2014/main" id="{F2FD41A1-9136-4C67-3DD6-3B225D1F29F5}"/>
               </a:ext>
             </a:extLst>
@@ -8202,7 +8408,7 @@
 </p:sld>
 </file>
 
-<file path=ppt/slides/slide18.xml><?xml version="1.0" encoding="utf-8"?>
+<file path=ppt/slides/slide19.xml><?xml version="1.0" encoding="utf-8"?>
 <p:sld xmlns:a="http://schemas.openxmlformats.org/drawingml/2006/main" xmlns:r="http://schemas.openxmlformats.org/officeDocument/2006/relationships" xmlns:p="http://schemas.openxmlformats.org/presentationml/2006/main">
   <p:cSld>
     <p:spTree>
@@ -8406,191 +8612,6 @@
     <p:extLst>
       <p:ext uri="{BB962C8B-B14F-4D97-AF65-F5344CB8AC3E}">
         <p14:creationId xmlns:p14="http://schemas.microsoft.com/office/powerpoint/2010/main" val="784242391"/>
-      </p:ext>
-    </p:extLst>
-  </p:cSld>
-  <p:clrMapOvr>
-    <a:masterClrMapping/>
-  </p:clrMapOvr>
-</p:sld>
-</file>
-
-<file path=ppt/slides/slide19.xml><?xml version="1.0" encoding="utf-8"?>
-<p:sld xmlns:a="http://schemas.openxmlformats.org/drawingml/2006/main" xmlns:r="http://schemas.openxmlformats.org/officeDocument/2006/relationships" xmlns:p="http://schemas.openxmlformats.org/presentationml/2006/main">
-  <p:cSld>
-    <p:spTree>
-      <p:nvGrpSpPr>
-        <p:cNvPr id="1" name="">
-          <a:extLst>
-            <a:ext uri="{FF2B5EF4-FFF2-40B4-BE49-F238E27FC236}">
-              <a16:creationId xmlns:a16="http://schemas.microsoft.com/office/drawing/2014/main" id="{43B4D39D-853D-4CA6-D443-36E59E29D000}"/>
-            </a:ext>
-          </a:extLst>
-        </p:cNvPr>
-        <p:cNvGrpSpPr/>
-        <p:nvPr/>
-      </p:nvGrpSpPr>
-      <p:grpSpPr>
-        <a:xfrm>
-          <a:off x="0" y="0"/>
-          <a:ext cx="0" cy="0"/>
-          <a:chOff x="0" y="0"/>
-          <a:chExt cx="0" cy="0"/>
-        </a:xfrm>
-      </p:grpSpPr>
-      <p:sp>
-        <p:nvSpPr>
-          <p:cNvPr id="2" name="Title 1">
-            <a:extLst>
-              <a:ext uri="{FF2B5EF4-FFF2-40B4-BE49-F238E27FC236}">
-                <a16:creationId xmlns:a16="http://schemas.microsoft.com/office/drawing/2014/main" id="{BE39B412-DCB1-3C14-70CC-915F9FFC3858}"/>
-              </a:ext>
-            </a:extLst>
-          </p:cNvPr>
-          <p:cNvSpPr>
-            <a:spLocks noGrp="1"/>
-          </p:cNvSpPr>
-          <p:nvPr>
-            <p:ph type="title"/>
-          </p:nvPr>
-        </p:nvSpPr>
-        <p:spPr/>
-        <p:txBody>
-          <a:bodyPr/>
-          <a:lstStyle/>
-          <a:p>
-            <a:r>
-              <a:rPr lang="en-US" dirty="0"/>
-              <a:t>Where Latency, Cost, and Quality Degrade </a:t>
-            </a:r>
-            <a:endParaRPr lang="en-IN" dirty="0"/>
-          </a:p>
-        </p:txBody>
-      </p:sp>
-      <p:sp>
-        <p:nvSpPr>
-          <p:cNvPr id="3" name="Content Placeholder 2">
-            <a:extLst>
-              <a:ext uri="{FF2B5EF4-FFF2-40B4-BE49-F238E27FC236}">
-                <a16:creationId xmlns:a16="http://schemas.microsoft.com/office/drawing/2014/main" id="{04DEC22B-EF85-A57E-70D3-CF51274E4B9D}"/>
-              </a:ext>
-            </a:extLst>
-          </p:cNvPr>
-          <p:cNvSpPr>
-            <a:spLocks noGrp="1"/>
-          </p:cNvSpPr>
-          <p:nvPr>
-            <p:ph idx="1"/>
-          </p:nvPr>
-        </p:nvSpPr>
-        <p:spPr/>
-        <p:txBody>
-          <a:bodyPr>
-            <a:normAutofit fontScale="85000" lnSpcReduction="20000"/>
-          </a:bodyPr>
-          <a:lstStyle/>
-          <a:p>
-            <a:r>
-              <a:rPr lang="en-IN" b="1" dirty="0"/>
-              <a:t>Embeddings Stage</a:t>
-            </a:r>
-            <a:endParaRPr lang="en-IN" dirty="0"/>
-          </a:p>
-          <a:p>
-            <a:pPr lvl="1"/>
-            <a:r>
-              <a:rPr lang="en-IN" b="1" dirty="0"/>
-              <a:t>Latency</a:t>
-            </a:r>
-          </a:p>
-          <a:p>
-            <a:pPr lvl="2"/>
-            <a:r>
-              <a:rPr lang="en-IN" dirty="0"/>
-              <a:t>Happens during ingestion (mostly) </a:t>
-            </a:r>
-          </a:p>
-          <a:p>
-            <a:pPr lvl="2"/>
-            <a:r>
-              <a:rPr lang="en-IN" dirty="0"/>
-              <a:t>Query embedding is fast but adds slight delay </a:t>
-            </a:r>
-          </a:p>
-          <a:p>
-            <a:pPr lvl="1"/>
-            <a:endParaRPr lang="en-IN" dirty="0"/>
-          </a:p>
-          <a:p>
-            <a:pPr lvl="1"/>
-            <a:r>
-              <a:rPr lang="en-IN" b="1" dirty="0"/>
-              <a:t>Cost</a:t>
-            </a:r>
-          </a:p>
-          <a:p>
-            <a:pPr lvl="2"/>
-            <a:r>
-              <a:rPr lang="en-IN" dirty="0"/>
-              <a:t>Charged per token </a:t>
-            </a:r>
-          </a:p>
-          <a:p>
-            <a:pPr lvl="2"/>
-            <a:r>
-              <a:rPr lang="en-IN" dirty="0"/>
-              <a:t>Large document base → significant cost </a:t>
-            </a:r>
-          </a:p>
-          <a:p>
-            <a:pPr lvl="1"/>
-            <a:endParaRPr lang="en-IN" dirty="0"/>
-          </a:p>
-          <a:p>
-            <a:pPr lvl="1"/>
-            <a:r>
-              <a:rPr lang="en-IN" b="1" dirty="0"/>
-              <a:t>Quality Risks</a:t>
-            </a:r>
-          </a:p>
-          <a:p>
-            <a:pPr lvl="2"/>
-            <a:r>
-              <a:rPr lang="en-IN" dirty="0"/>
-              <a:t>Poor embedding model → weak semantic understanding </a:t>
-            </a:r>
-          </a:p>
-          <a:p>
-            <a:pPr lvl="2"/>
-            <a:r>
-              <a:rPr lang="en-IN" dirty="0"/>
-              <a:t>Domain mismatch (e.g., legal vs general embeddings) </a:t>
-            </a:r>
-          </a:p>
-          <a:p>
-            <a:pPr lvl="2"/>
-            <a:endParaRPr lang="en-IN" dirty="0"/>
-          </a:p>
-          <a:p>
-            <a:pPr lvl="1"/>
-            <a:r>
-              <a:rPr lang="en-IN" b="1" dirty="0"/>
-              <a:t>Example:</a:t>
-            </a:r>
-          </a:p>
-          <a:p>
-            <a:pPr lvl="2"/>
-            <a:r>
-              <a:rPr lang="en-IN" dirty="0"/>
-              <a:t>“Penalty clause” not matched with “liquidated damages”</a:t>
-            </a:r>
-          </a:p>
-        </p:txBody>
-      </p:sp>
-    </p:spTree>
-    <p:extLst>
-      <p:ext uri="{BB962C8B-B14F-4D97-AF65-F5344CB8AC3E}">
-        <p14:creationId xmlns:p14="http://schemas.microsoft.com/office/powerpoint/2010/main" val="2258458022"/>
       </p:ext>
     </p:extLst>
   </p:cSld>
@@ -9421,6 +9442,191 @@
         <p:cNvPr id="1" name="">
           <a:extLst>
             <a:ext uri="{FF2B5EF4-FFF2-40B4-BE49-F238E27FC236}">
+              <a16:creationId xmlns:a16="http://schemas.microsoft.com/office/drawing/2014/main" id="{43B4D39D-853D-4CA6-D443-36E59E29D000}"/>
+            </a:ext>
+          </a:extLst>
+        </p:cNvPr>
+        <p:cNvGrpSpPr/>
+        <p:nvPr/>
+      </p:nvGrpSpPr>
+      <p:grpSpPr>
+        <a:xfrm>
+          <a:off x="0" y="0"/>
+          <a:ext cx="0" cy="0"/>
+          <a:chOff x="0" y="0"/>
+          <a:chExt cx="0" cy="0"/>
+        </a:xfrm>
+      </p:grpSpPr>
+      <p:sp>
+        <p:nvSpPr>
+          <p:cNvPr id="2" name="Title 1">
+            <a:extLst>
+              <a:ext uri="{FF2B5EF4-FFF2-40B4-BE49-F238E27FC236}">
+                <a16:creationId xmlns:a16="http://schemas.microsoft.com/office/drawing/2014/main" id="{BE39B412-DCB1-3C14-70CC-915F9FFC3858}"/>
+              </a:ext>
+            </a:extLst>
+          </p:cNvPr>
+          <p:cNvSpPr>
+            <a:spLocks noGrp="1"/>
+          </p:cNvSpPr>
+          <p:nvPr>
+            <p:ph type="title"/>
+          </p:nvPr>
+        </p:nvSpPr>
+        <p:spPr/>
+        <p:txBody>
+          <a:bodyPr/>
+          <a:lstStyle/>
+          <a:p>
+            <a:r>
+              <a:rPr lang="en-US" dirty="0"/>
+              <a:t>Where Latency, Cost, and Quality Degrade </a:t>
+            </a:r>
+            <a:endParaRPr lang="en-IN" dirty="0"/>
+          </a:p>
+        </p:txBody>
+      </p:sp>
+      <p:sp>
+        <p:nvSpPr>
+          <p:cNvPr id="3" name="Content Placeholder 2">
+            <a:extLst>
+              <a:ext uri="{FF2B5EF4-FFF2-40B4-BE49-F238E27FC236}">
+                <a16:creationId xmlns:a16="http://schemas.microsoft.com/office/drawing/2014/main" id="{04DEC22B-EF85-A57E-70D3-CF51274E4B9D}"/>
+              </a:ext>
+            </a:extLst>
+          </p:cNvPr>
+          <p:cNvSpPr>
+            <a:spLocks noGrp="1"/>
+          </p:cNvSpPr>
+          <p:nvPr>
+            <p:ph idx="1"/>
+          </p:nvPr>
+        </p:nvSpPr>
+        <p:spPr/>
+        <p:txBody>
+          <a:bodyPr>
+            <a:normAutofit fontScale="85000" lnSpcReduction="20000"/>
+          </a:bodyPr>
+          <a:lstStyle/>
+          <a:p>
+            <a:r>
+              <a:rPr lang="en-IN" b="1" dirty="0"/>
+              <a:t>Embeddings Stage</a:t>
+            </a:r>
+            <a:endParaRPr lang="en-IN" dirty="0"/>
+          </a:p>
+          <a:p>
+            <a:pPr lvl="1"/>
+            <a:r>
+              <a:rPr lang="en-IN" b="1" dirty="0"/>
+              <a:t>Latency</a:t>
+            </a:r>
+          </a:p>
+          <a:p>
+            <a:pPr lvl="2"/>
+            <a:r>
+              <a:rPr lang="en-IN" dirty="0"/>
+              <a:t>Happens during ingestion (mostly) </a:t>
+            </a:r>
+          </a:p>
+          <a:p>
+            <a:pPr lvl="2"/>
+            <a:r>
+              <a:rPr lang="en-IN" dirty="0"/>
+              <a:t>Query embedding is fast but adds slight delay </a:t>
+            </a:r>
+          </a:p>
+          <a:p>
+            <a:pPr lvl="1"/>
+            <a:endParaRPr lang="en-IN" dirty="0"/>
+          </a:p>
+          <a:p>
+            <a:pPr lvl="1"/>
+            <a:r>
+              <a:rPr lang="en-IN" b="1" dirty="0"/>
+              <a:t>Cost</a:t>
+            </a:r>
+          </a:p>
+          <a:p>
+            <a:pPr lvl="2"/>
+            <a:r>
+              <a:rPr lang="en-IN" dirty="0"/>
+              <a:t>Charged per token </a:t>
+            </a:r>
+          </a:p>
+          <a:p>
+            <a:pPr lvl="2"/>
+            <a:r>
+              <a:rPr lang="en-IN" dirty="0"/>
+              <a:t>Large document base → significant cost </a:t>
+            </a:r>
+          </a:p>
+          <a:p>
+            <a:pPr lvl="1"/>
+            <a:endParaRPr lang="en-IN" dirty="0"/>
+          </a:p>
+          <a:p>
+            <a:pPr lvl="1"/>
+            <a:r>
+              <a:rPr lang="en-IN" b="1" dirty="0"/>
+              <a:t>Quality Risks</a:t>
+            </a:r>
+          </a:p>
+          <a:p>
+            <a:pPr lvl="2"/>
+            <a:r>
+              <a:rPr lang="en-IN" dirty="0"/>
+              <a:t>Poor embedding model → weak semantic understanding </a:t>
+            </a:r>
+          </a:p>
+          <a:p>
+            <a:pPr lvl="2"/>
+            <a:r>
+              <a:rPr lang="en-IN" dirty="0"/>
+              <a:t>Domain mismatch (e.g., legal vs general embeddings) </a:t>
+            </a:r>
+          </a:p>
+          <a:p>
+            <a:pPr lvl="2"/>
+            <a:endParaRPr lang="en-IN" dirty="0"/>
+          </a:p>
+          <a:p>
+            <a:pPr lvl="1"/>
+            <a:r>
+              <a:rPr lang="en-IN" b="1" dirty="0"/>
+              <a:t>Example:</a:t>
+            </a:r>
+          </a:p>
+          <a:p>
+            <a:pPr lvl="2"/>
+            <a:r>
+              <a:rPr lang="en-IN" dirty="0"/>
+              <a:t>“Penalty clause” not matched with “liquidated damages”</a:t>
+            </a:r>
+          </a:p>
+        </p:txBody>
+      </p:sp>
+    </p:spTree>
+    <p:extLst>
+      <p:ext uri="{BB962C8B-B14F-4D97-AF65-F5344CB8AC3E}">
+        <p14:creationId xmlns:p14="http://schemas.microsoft.com/office/powerpoint/2010/main" val="2258458022"/>
+      </p:ext>
+    </p:extLst>
+  </p:cSld>
+  <p:clrMapOvr>
+    <a:masterClrMapping/>
+  </p:clrMapOvr>
+</p:sld>
+</file>
+
+<file path=ppt/slides/slide21.xml><?xml version="1.0" encoding="utf-8"?>
+<p:sld xmlns:a="http://schemas.openxmlformats.org/drawingml/2006/main" xmlns:r="http://schemas.openxmlformats.org/officeDocument/2006/relationships" xmlns:p="http://schemas.openxmlformats.org/presentationml/2006/main">
+  <p:cSld>
+    <p:spTree>
+      <p:nvGrpSpPr>
+        <p:cNvPr id="1" name="">
+          <a:extLst>
+            <a:ext uri="{FF2B5EF4-FFF2-40B4-BE49-F238E27FC236}">
               <a16:creationId xmlns:a16="http://schemas.microsoft.com/office/drawing/2014/main" id="{C40CBD90-B059-F6E3-A3E9-35FDD97AFBCA}"/>
             </a:ext>
           </a:extLst>
@@ -9623,7 +9829,7 @@
 </p:sld>
 </file>
 
-<file path=ppt/slides/slide21.xml><?xml version="1.0" encoding="utf-8"?>
+<file path=ppt/slides/slide22.xml><?xml version="1.0" encoding="utf-8"?>
 <p:sld xmlns:a="http://schemas.openxmlformats.org/drawingml/2006/main" xmlns:r="http://schemas.openxmlformats.org/officeDocument/2006/relationships" xmlns:p="http://schemas.openxmlformats.org/presentationml/2006/main">
   <p:cSld>
     <p:spTree>
@@ -9815,7 +10021,7 @@
 </p:sld>
 </file>
 
-<file path=ppt/slides/slide22.xml><?xml version="1.0" encoding="utf-8"?>
+<file path=ppt/slides/slide23.xml><?xml version="1.0" encoding="utf-8"?>
 <p:sld xmlns:a="http://schemas.openxmlformats.org/drawingml/2006/main" xmlns:r="http://schemas.openxmlformats.org/officeDocument/2006/relationships" xmlns:p="http://schemas.openxmlformats.org/presentationml/2006/main">
   <p:cSld>
     <p:spTree>
@@ -9911,7 +10117,7 @@
 </p:sld>
 </file>
 
-<file path=ppt/slides/slide23.xml><?xml version="1.0" encoding="utf-8"?>
+<file path=ppt/slides/slide24.xml><?xml version="1.0" encoding="utf-8"?>
 <p:sld xmlns:a="http://schemas.openxmlformats.org/drawingml/2006/main" xmlns:r="http://schemas.openxmlformats.org/officeDocument/2006/relationships" xmlns:p="http://schemas.openxmlformats.org/presentationml/2006/main">
   <p:cSld>
     <p:spTree>

</xml_diff>